<commit_message>
feat(setup): idempotent setup command with Node.js and Playwright management
Replaces the unconditional install/update with a smart setup that:
- Checks Node.js major version and installs/upgrades only when needed
  (via brew/apt-get/dnf/choco depending on platform)
- Skips Playwright npm install when node_modules already contains it;
  only runs `npm update playwright` when `npm outdated` reports a newer
  version; honours PLAYWRIGHT_SKIP_BROWSER_DOWNLOAD for CI
- Extracts all setup helpers into SetupManager to keep Cli under the
  200-line Rubocop ClassLength limit
- bin/setup becomes a thin 2-line bootstrapper; CI uses single
  PLAYWRIGHT_SKIP_BROWSER_DOWNLOAD=1 ./bin/setup invocation
- Updates gemspec post_install_message; removes --skip-playwright /
  --skip-bundle flags; bumps nokogiri to 1.19.3 (CVE fix)

Co-Authored-By: Claude <noreply@anthropic.com>
</commit_message>
<xml_diff>
--- a/data/samples/reports/sample_data/dashboard.pptx
+++ b/data/samples/reports/sample_data/dashboard.pptx
@@ -6,6 +6,7 @@
   </p:sldMasterIdLst>
   <p:sldIdLst>
     <p:sldId id="256" r:id="rId6"/>
+    <p:sldId id="257" r:id="rId7"/>
   </p:sldIdLst>
   <p:sldSz cx="9144000" cy="6858000" type="screen4x3"/>
   <p:notesSz cx="6858000" cy="9144000"/>
@@ -3082,7 +3083,7 @@
             <a:spLocks noGrp="1"/>
           </p:cNvSpPr>
           <p:nvPr>
-            <p:ph type="title"/>
+            <p:ph type="ctrTitle"/>
           </p:nvPr>
         </p:nvSpPr>
         <p:spPr/>
@@ -3098,42 +3099,193 @@
           </a:p>
         </p:txBody>
       </p:sp>
-      <p:pic>
-        <p:nvPicPr>
-          <p:cNvPr id="4" name="Content Placeholder 3"/>
-          <p:cNvPicPr>
-            <a:picLocks noChangeAspect="1" noGrp="1"/>
-          </p:cNvPicPr>
-          <p:nvPr>
-            <p:ph idx="1"/>
-          </p:nvPr>
-        </p:nvPicPr>
-        <p:blipFill>
-          <a:blip r:embed="rId2">
-            <a:extLst>
-              <a:ext uri="{28A0092B-C50C-407E-A947-70E740481C1C}">
-                <a14:useLocalDpi xmlns:a14="http://schemas.microsoft.com/office/drawing/2010/main" val="0"/>
-              </a:ext>
-            </a:extLst>
-          </a:blip>
-          <a:stretch>
-            <a:fillRect/>
-          </a:stretch>
-        </p:blipFill>
-        <p:spPr>
-          <a:xfrm>
-            <a:off x="1079500" y="1524000"/>
-            <a:ext cx="6985000" cy="4938300"/>
-          </a:xfrm>
-          <a:prstGeom prst="rect">
-            <a:avLst/>
-          </a:prstGeom>
-        </p:spPr>
-      </p:pic>
+      <p:sp>
+        <p:nvSpPr>
+          <p:cNvPr id="3" name="Subtitle 2"/>
+          <p:cNvSpPr>
+            <a:spLocks noGrp="1"/>
+          </p:cNvSpPr>
+          <p:nvPr>
+            <p:ph idx="1" type="subTitle"/>
+          </p:nvPr>
+        </p:nvSpPr>
+        <p:spPr/>
+        <p:txBody>
+          <a:bodyPr/>
+          <a:lstStyle/>
+          <a:p>
+            <a:r>
+              <a:rPr lang="en-US" smtClean="0"/>
+              <a:t>Generated on 2026-05-12 23:19</a:t>
+            </a:r>
+            <a:endParaRPr lang="en-US"/>
+          </a:p>
+        </p:txBody>
+      </p:sp>
     </p:spTree>
     <p:extLst>
       <p:ext uri="{BB962C8B-B14F-4D97-AF65-F5344CB8AC3E}">
-        <p14:creationId xmlns:p14="http://schemas.microsoft.com/office/powerpoint/2010/main" val="1474098577"/>
+        <p14:creationId xmlns:p14="http://schemas.microsoft.com/office/powerpoint/2010/main" val="1633108117"/>
+      </p:ext>
+    </p:extLst>
+  </p:cSld>
+  <p:clrMapOvr>
+    <a:masterClrMapping/>
+  </p:clrMapOvr>
+</p:sld>
+</file>
+
+<file path=ppt/slides/slide2.xml><?xml version="1.0" encoding="utf-8"?>
+<p:sld xmlns:a="http://schemas.openxmlformats.org/drawingml/2006/main" xmlns:p="http://schemas.openxmlformats.org/presentationml/2006/main" xmlns:r="http://schemas.openxmlformats.org/officeDocument/2006/relationships">
+  <p:cSld>
+    <p:spTree>
+      <p:nvGrpSpPr>
+        <p:cNvPr id="1" name=""/>
+        <p:cNvGrpSpPr/>
+        <p:nvPr/>
+      </p:nvGrpSpPr>
+      <p:grpSpPr>
+        <a:xfrm>
+          <a:off x="0" y="0"/>
+          <a:ext cx="0" cy="0"/>
+          <a:chOff x="0" y="0"/>
+          <a:chExt cx="0" cy="0"/>
+        </a:xfrm>
+      </p:grpSpPr>
+      <p:sp>
+        <p:nvSpPr>
+          <p:cNvPr id="2" name="Title 1"/>
+          <p:cNvSpPr>
+            <a:spLocks noGrp="1"/>
+          </p:cNvSpPr>
+          <p:nvPr>
+            <p:ph type="title"/>
+          </p:nvPr>
+        </p:nvSpPr>
+        <p:spPr/>
+        <p:txBody>
+          <a:bodyPr/>
+          <a:lstStyle/>
+          <a:p>
+            <a:r>
+              <a:rPr dirty="0" lang="en-US" smtClean="0"/>
+              <a:t>Flow Metrics Summary</a:t>
+            </a:r>
+            <a:endParaRPr dirty="0" lang="en-US"/>
+          </a:p>
+        </p:txBody>
+      </p:sp>
+      <p:sp>
+        <p:nvSpPr>
+          <p:cNvPr id="3" name="Content Placeholder 2"/>
+          <p:cNvSpPr>
+            <a:spLocks noGrp="1"/>
+          </p:cNvSpPr>
+          <p:nvPr>
+            <p:ph idx="1"/>
+          </p:nvPr>
+        </p:nvSpPr>
+        <p:spPr/>
+        <p:txBody>
+          <a:bodyPr/>
+          <a:lstStyle/>
+          <a:p>
+            <a:r>
+              <a:rPr dirty="0" lang="en-US" smtClean="0"/>
+              <a:t>Flow Metrics Summary</a:t>
+            </a:r>
+          </a:p>
+          <a:p>
+            <a:r>
+              <a:rPr dirty="0" lang="en-US" smtClean="0"/>
+              <a:t>--------------------</a:t>
+            </a:r>
+          </a:p>
+          <a:p>
+            <a:r>
+              <a:rPr dirty="0" lang="en-US" smtClean="0"/>
+              <a:t>Total Items: 18</a:t>
+            </a:r>
+          </a:p>
+          <a:p>
+            <a:r>
+              <a:rPr dirty="0" lang="en-US" smtClean="0"/>
+              <a:t>Completed Items: 15</a:t>
+            </a:r>
+          </a:p>
+          <a:p>
+            <a:r>
+              <a:rPr dirty="0" lang="en-US" smtClean="0"/>
+              <a:t>Average Throughput: 0.42 items/day</a:t>
+            </a:r>
+          </a:p>
+          <a:p>
+            <a:r>
+              <a:rPr dirty="0" lang="en-US" smtClean="0"/>
+              <a:t>Aging WIP Summary:</a:t>
+            </a:r>
+          </a:p>
+          <a:p>
+            <a:r>
+              <a:rPr dirty="0" lang="en-US" smtClean="0"/>
+              <a:t>Active WIP: 3 items</a:t>
+            </a:r>
+          </a:p>
+          <a:p>
+            <a:r>
+              <a:rPr dirty="0" lang="en-US" smtClean="0"/>
+              <a:t>Average WIP Age: 40.0 days</a:t>
+            </a:r>
+          </a:p>
+          <a:p>
+            <a:r>
+              <a:rPr dirty="0" lang="en-US" smtClean="0"/>
+              <a:t>Oldest Item Age: 42 days</a:t>
+            </a:r>
+          </a:p>
+          <a:p>
+            <a:r>
+              <a:rPr dirty="0" lang="en-US" smtClean="0"/>
+              <a:t>Cycle Time Percentiles:</a:t>
+            </a:r>
+          </a:p>
+          <a:p>
+            <a:r>
+              <a:rPr dirty="0" lang="en-US" smtClean="0"/>
+              <a:t>50th Percentile: 7 days</a:t>
+            </a:r>
+          </a:p>
+          <a:p>
+            <a:r>
+              <a:rPr dirty="0" lang="en-US" smtClean="0"/>
+              <a:t>75th Percentile: 11 days</a:t>
+            </a:r>
+          </a:p>
+          <a:p>
+            <a:r>
+              <a:rPr dirty="0" lang="en-US" smtClean="0"/>
+              <a:t>85th Percentile: 11 days</a:t>
+            </a:r>
+          </a:p>
+          <a:p>
+            <a:r>
+              <a:rPr dirty="0" lang="en-US" smtClean="0"/>
+              <a:t>95th Percentile: 12 days</a:t>
+            </a:r>
+          </a:p>
+          <a:p>
+            <a:r>
+              <a:rPr dirty="0" lang="en-US" smtClean="0"/>
+              <a:t>98th Percentile: 12 days</a:t>
+            </a:r>
+            <a:endParaRPr lang="en-US"/>
+          </a:p>
+        </p:txBody>
+      </p:sp>
+    </p:spTree>
+    <p:extLst>
+      <p:ext uri="{BB962C8B-B14F-4D97-AF65-F5344CB8AC3E}">
+        <p14:creationId xmlns:p14="http://schemas.microsoft.com/office/powerpoint/2010/main" val="1231192379"/>
       </p:ext>
     </p:extLst>
   </p:cSld>

</xml_diff>

<commit_message>
chore: bump version to 0.5.0
Co-Authored-By: Claude <noreply@anthropic.com>
</commit_message>
<xml_diff>
--- a/data/samples/reports/sample_data/dashboard.pptx
+++ b/data/samples/reports/sample_data/dashboard.pptx
@@ -3116,7 +3116,7 @@
           <a:p>
             <a:r>
               <a:rPr lang="en-US" smtClean="0"/>
-              <a:t>Generated on 2026-05-12 23:20</a:t>
+              <a:t>Generated on 2026-05-13 06:39</a:t>
             </a:r>
             <a:endParaRPr lang="en-US"/>
           </a:p>
@@ -3234,13 +3234,13 @@
           <a:p>
             <a:r>
               <a:rPr dirty="0" lang="en-US" smtClean="0"/>
-              <a:t>Average WIP Age: 40.0 days</a:t>
+              <a:t>Average WIP Age: 41.0 days</a:t>
             </a:r>
           </a:p>
           <a:p>
             <a:r>
               <a:rPr dirty="0" lang="en-US" smtClean="0"/>
-              <a:t>Oldest Item Age: 42 days</a:t>
+              <a:t>Oldest Item Age: 43 days</a:t>
             </a:r>
           </a:p>
           <a:p>

</xml_diff>

<commit_message>
refactor(publish): use GemPublisher from rake-gem-maintenance for rubygems.org push
Replace the raw `gem push` shell commands in the publish-rubygems CI step
with `bundle exec rake publish:rubygems`, backed by GemPublisher and Repos
from rake-gem-maintenance. Adds a local publish:rubygems rake task so CI
and local publish paths are identical.

Co-Authored-By: Claude Sonnet 4.6 <noreply@anthropic.com>
</commit_message>
<xml_diff>
--- a/data/samples/reports/sample_data/dashboard.pptx
+++ b/data/samples/reports/sample_data/dashboard.pptx
@@ -3116,7 +3116,7 @@
           <a:p>
             <a:r>
               <a:rPr lang="en-US" smtClean="0"/>
-              <a:t>Generated on 2026-05-13 06:44</a:t>
+              <a:t>Generated on 2026-05-15 20:51</a:t>
             </a:r>
             <a:endParaRPr lang="en-US"/>
           </a:p>
@@ -3234,13 +3234,13 @@
           <a:p>
             <a:r>
               <a:rPr dirty="0" lang="en-US" smtClean="0"/>
-              <a:t>Average WIP Age: 41.0 days</a:t>
+              <a:t>Average WIP Age: 43.0 days</a:t>
             </a:r>
           </a:p>
           <a:p>
             <a:r>
               <a:rPr dirty="0" lang="en-US" smtClean="0"/>
-              <a:t>Oldest Item Age: 43 days</a:t>
+              <a:t>Oldest Item Age: 45 days</a:t>
             </a:r>
           </a:p>
           <a:p>

</xml_diff>

<commit_message>
refactor(publish): use rake-gem-maintenance 0.1.6 auth for rubygems.org push
Bump rake-gem-maintenance 0.1.4 → 0.1.6, which ships GemPush, OtpProvider,
CredentialStore, ApiKeyRenewer, and WoodpeckerSecretStore. The publish:rubygems
rake task now automatically benefits from OTP injection (RUBYGEMS_OTP_SEED →
TOTP code via rotp) and auto key-renewal on auth failure (RUBYGEMS_USERNAME +
RUBYGEMS_PASSWORD → new key persisted back to Woodpecker secret).

Add RenewApiKeyTask to the Rakefile so `upgrade:renew_api_key` is available
locally for first-time and rotated key setup.

Extend the publish-rubygems CI step with RUBYGEMS_OTP_SEED, RUBYGEMS_USERNAME,
RUBYGEMS_PASSWORD, and WOODPECKER_TOKEN secrets so ApiKeyRenewer can operate
unattended in CI.

Co-Authored-By: Claude Sonnet 4.6 <noreply@anthropic.com>
</commit_message>
<xml_diff>
--- a/data/samples/reports/sample_data/dashboard.pptx
+++ b/data/samples/reports/sample_data/dashboard.pptx
@@ -3116,7 +3116,7 @@
           <a:p>
             <a:r>
               <a:rPr lang="en-US" smtClean="0"/>
-              <a:t>Generated on 2026-05-15 20:51</a:t>
+              <a:t>Generated on 2026-05-16 08:09</a:t>
             </a:r>
             <a:endParaRPr lang="en-US"/>
           </a:p>
@@ -3234,13 +3234,13 @@
           <a:p>
             <a:r>
               <a:rPr dirty="0" lang="en-US" smtClean="0"/>
-              <a:t>Average WIP Age: 43.0 days</a:t>
+              <a:t>Average WIP Age: 44.0 days</a:t>
             </a:r>
           </a:p>
           <a:p>
             <a:r>
               <a:rPr dirty="0" lang="en-US" smtClean="0"/>
-              <a:t>Oldest Item Age: 45 days</a:t>
+              <a:t>Oldest Item Age: 46 days</a:t>
             </a:r>
           </a:p>
           <a:p>

</xml_diff>

<commit_message>
doc(todo): add notes on removing obsolete README sections and evaluating Packwerk integration
</commit_message>
<xml_diff>
--- a/data/samples/reports/sample_data/dashboard.pptx
+++ b/data/samples/reports/sample_data/dashboard.pptx
@@ -6,7 +6,6 @@
   </p:sldMasterIdLst>
   <p:sldIdLst>
     <p:sldId id="256" r:id="rId6"/>
-    <p:sldId id="257" r:id="rId7"/>
   </p:sldIdLst>
   <p:sldSz cx="9144000" cy="6858000" type="screen4x3"/>
   <p:notesSz cx="6858000" cy="9144000"/>
@@ -3083,7 +3082,7 @@
             <a:spLocks noGrp="1"/>
           </p:cNvSpPr>
           <p:nvPr>
-            <p:ph type="ctrTitle"/>
+            <p:ph type="title"/>
           </p:nvPr>
         </p:nvSpPr>
         <p:spPr/>
@@ -3099,193 +3098,42 @@
           </a:p>
         </p:txBody>
       </p:sp>
-      <p:sp>
-        <p:nvSpPr>
-          <p:cNvPr id="3" name="Subtitle 2"/>
-          <p:cNvSpPr>
-            <a:spLocks noGrp="1"/>
-          </p:cNvSpPr>
-          <p:nvPr>
-            <p:ph idx="1" type="subTitle"/>
-          </p:nvPr>
-        </p:nvSpPr>
-        <p:spPr/>
-        <p:txBody>
-          <a:bodyPr/>
-          <a:lstStyle/>
-          <a:p>
-            <a:r>
-              <a:rPr lang="en-US" smtClean="0"/>
-              <a:t>Generated on 2026-05-16 08:34</a:t>
-            </a:r>
-            <a:endParaRPr lang="en-US"/>
-          </a:p>
-        </p:txBody>
-      </p:sp>
+      <p:pic>
+        <p:nvPicPr>
+          <p:cNvPr id="4" name="Content Placeholder 3"/>
+          <p:cNvPicPr>
+            <a:picLocks noChangeAspect="1" noGrp="1"/>
+          </p:cNvPicPr>
+          <p:nvPr>
+            <p:ph idx="1"/>
+          </p:nvPr>
+        </p:nvPicPr>
+        <p:blipFill>
+          <a:blip r:embed="rId2">
+            <a:extLst>
+              <a:ext uri="{28A0092B-C50C-407E-A947-70E740481C1C}">
+                <a14:useLocalDpi xmlns:a14="http://schemas.microsoft.com/office/drawing/2010/main" val="0"/>
+              </a:ext>
+            </a:extLst>
+          </a:blip>
+          <a:stretch>
+            <a:fillRect/>
+          </a:stretch>
+        </p:blipFill>
+        <p:spPr>
+          <a:xfrm>
+            <a:off x="1079500" y="1524000"/>
+            <a:ext cx="6985000" cy="4938300"/>
+          </a:xfrm>
+          <a:prstGeom prst="rect">
+            <a:avLst/>
+          </a:prstGeom>
+        </p:spPr>
+      </p:pic>
     </p:spTree>
     <p:extLst>
       <p:ext uri="{BB962C8B-B14F-4D97-AF65-F5344CB8AC3E}">
-        <p14:creationId xmlns:p14="http://schemas.microsoft.com/office/powerpoint/2010/main" val="1633108117"/>
-      </p:ext>
-    </p:extLst>
-  </p:cSld>
-  <p:clrMapOvr>
-    <a:masterClrMapping/>
-  </p:clrMapOvr>
-</p:sld>
-</file>
-
-<file path=ppt/slides/slide2.xml><?xml version="1.0" encoding="utf-8"?>
-<p:sld xmlns:a="http://schemas.openxmlformats.org/drawingml/2006/main" xmlns:p="http://schemas.openxmlformats.org/presentationml/2006/main" xmlns:r="http://schemas.openxmlformats.org/officeDocument/2006/relationships">
-  <p:cSld>
-    <p:spTree>
-      <p:nvGrpSpPr>
-        <p:cNvPr id="1" name=""/>
-        <p:cNvGrpSpPr/>
-        <p:nvPr/>
-      </p:nvGrpSpPr>
-      <p:grpSpPr>
-        <a:xfrm>
-          <a:off x="0" y="0"/>
-          <a:ext cx="0" cy="0"/>
-          <a:chOff x="0" y="0"/>
-          <a:chExt cx="0" cy="0"/>
-        </a:xfrm>
-      </p:grpSpPr>
-      <p:sp>
-        <p:nvSpPr>
-          <p:cNvPr id="2" name="Title 1"/>
-          <p:cNvSpPr>
-            <a:spLocks noGrp="1"/>
-          </p:cNvSpPr>
-          <p:nvPr>
-            <p:ph type="title"/>
-          </p:nvPr>
-        </p:nvSpPr>
-        <p:spPr/>
-        <p:txBody>
-          <a:bodyPr/>
-          <a:lstStyle/>
-          <a:p>
-            <a:r>
-              <a:rPr dirty="0" lang="en-US" smtClean="0"/>
-              <a:t>Flow Metrics Summary</a:t>
-            </a:r>
-            <a:endParaRPr dirty="0" lang="en-US"/>
-          </a:p>
-        </p:txBody>
-      </p:sp>
-      <p:sp>
-        <p:nvSpPr>
-          <p:cNvPr id="3" name="Content Placeholder 2"/>
-          <p:cNvSpPr>
-            <a:spLocks noGrp="1"/>
-          </p:cNvSpPr>
-          <p:nvPr>
-            <p:ph idx="1"/>
-          </p:nvPr>
-        </p:nvSpPr>
-        <p:spPr/>
-        <p:txBody>
-          <a:bodyPr/>
-          <a:lstStyle/>
-          <a:p>
-            <a:r>
-              <a:rPr dirty="0" lang="en-US" smtClean="0"/>
-              <a:t>Flow Metrics Summary</a:t>
-            </a:r>
-          </a:p>
-          <a:p>
-            <a:r>
-              <a:rPr dirty="0" lang="en-US" smtClean="0"/>
-              <a:t>--------------------</a:t>
-            </a:r>
-          </a:p>
-          <a:p>
-            <a:r>
-              <a:rPr dirty="0" lang="en-US" smtClean="0"/>
-              <a:t>Total Items: 18</a:t>
-            </a:r>
-          </a:p>
-          <a:p>
-            <a:r>
-              <a:rPr dirty="0" lang="en-US" smtClean="0"/>
-              <a:t>Completed Items: 15</a:t>
-            </a:r>
-          </a:p>
-          <a:p>
-            <a:r>
-              <a:rPr dirty="0" lang="en-US" smtClean="0"/>
-              <a:t>Average Throughput: 0.42 items/day</a:t>
-            </a:r>
-          </a:p>
-          <a:p>
-            <a:r>
-              <a:rPr dirty="0" lang="en-US" smtClean="0"/>
-              <a:t>Aging WIP Summary:</a:t>
-            </a:r>
-          </a:p>
-          <a:p>
-            <a:r>
-              <a:rPr dirty="0" lang="en-US" smtClean="0"/>
-              <a:t>Active WIP: 3 items</a:t>
-            </a:r>
-          </a:p>
-          <a:p>
-            <a:r>
-              <a:rPr dirty="0" lang="en-US" smtClean="0"/>
-              <a:t>Average WIP Age: 44.0 days</a:t>
-            </a:r>
-          </a:p>
-          <a:p>
-            <a:r>
-              <a:rPr dirty="0" lang="en-US" smtClean="0"/>
-              <a:t>Oldest Item Age: 46 days</a:t>
-            </a:r>
-          </a:p>
-          <a:p>
-            <a:r>
-              <a:rPr dirty="0" lang="en-US" smtClean="0"/>
-              <a:t>Cycle Time Percentiles:</a:t>
-            </a:r>
-          </a:p>
-          <a:p>
-            <a:r>
-              <a:rPr dirty="0" lang="en-US" smtClean="0"/>
-              <a:t>50th Percentile: 7 days</a:t>
-            </a:r>
-          </a:p>
-          <a:p>
-            <a:r>
-              <a:rPr dirty="0" lang="en-US" smtClean="0"/>
-              <a:t>75th Percentile: 11 days</a:t>
-            </a:r>
-          </a:p>
-          <a:p>
-            <a:r>
-              <a:rPr dirty="0" lang="en-US" smtClean="0"/>
-              <a:t>85th Percentile: 11 days</a:t>
-            </a:r>
-          </a:p>
-          <a:p>
-            <a:r>
-              <a:rPr dirty="0" lang="en-US" smtClean="0"/>
-              <a:t>95th Percentile: 12 days</a:t>
-            </a:r>
-          </a:p>
-          <a:p>
-            <a:r>
-              <a:rPr dirty="0" lang="en-US" smtClean="0"/>
-              <a:t>98th Percentile: 12 days</a:t>
-            </a:r>
-            <a:endParaRPr lang="en-US"/>
-          </a:p>
-        </p:txBody>
-      </p:sp>
-    </p:spTree>
-    <p:extLst>
-      <p:ext uri="{BB962C8B-B14F-4D97-AF65-F5344CB8AC3E}">
-        <p14:creationId xmlns:p14="http://schemas.microsoft.com/office/powerpoint/2010/main" val="1231192379"/>
+        <p14:creationId xmlns:p14="http://schemas.microsoft.com/office/powerpoint/2010/main" val="1474098577"/>
       </p:ext>
     </p:extLst>
   </p:cSld>

</xml_diff>